<commit_message>
TESLA Updates. SQL project initialized
</commit_message>
<xml_diff>
--- a/References/ProjectSnaps.pptx
+++ b/References/ProjectSnaps.pptx
@@ -7,6 +7,11 @@
   <p:sldIdLst>
     <p:sldId id="256" r:id="rId2"/>
     <p:sldId id="257" r:id="rId3"/>
+    <p:sldId id="258" r:id="rId4"/>
+    <p:sldId id="259" r:id="rId5"/>
+    <p:sldId id="260" r:id="rId6"/>
+    <p:sldId id="261" r:id="rId7"/>
+    <p:sldId id="262" r:id="rId8"/>
   </p:sldIdLst>
   <p:sldSz cx="12192000" cy="6858000"/>
   <p:notesSz cx="6858000" cy="9144000"/>
@@ -105,6 +110,11 @@
       </a:defRPr>
     </a:lvl9pPr>
   </p:defaultTextStyle>
+  <p:extLst>
+    <p:ext uri="{EFAFB233-063F-42B5-8137-9DF3F51BA10A}">
+      <p15:sldGuideLst xmlns:p15="http://schemas.microsoft.com/office/powerpoint/2012/main"/>
+    </p:ext>
+  </p:extLst>
 </p:presentation>
 </file>
 
@@ -307,7 +317,7 @@
           <a:p>
             <a:fld id="{7DEE96FE-DC9C-4536-9FF4-6BA93424ACA5}" type="datetimeFigureOut">
               <a:rPr lang="en-US" smtClean="0"/>
-              <a:t>2/27/2026</a:t>
+              <a:t>2/28/2026</a:t>
             </a:fld>
             <a:endParaRPr lang="en-US"/>
           </a:p>
@@ -505,7 +515,7 @@
           <a:p>
             <a:fld id="{7DEE96FE-DC9C-4536-9FF4-6BA93424ACA5}" type="datetimeFigureOut">
               <a:rPr lang="en-US" smtClean="0"/>
-              <a:t>2/27/2026</a:t>
+              <a:t>2/28/2026</a:t>
             </a:fld>
             <a:endParaRPr lang="en-US"/>
           </a:p>
@@ -713,7 +723,7 @@
           <a:p>
             <a:fld id="{7DEE96FE-DC9C-4536-9FF4-6BA93424ACA5}" type="datetimeFigureOut">
               <a:rPr lang="en-US" smtClean="0"/>
-              <a:t>2/27/2026</a:t>
+              <a:t>2/28/2026</a:t>
             </a:fld>
             <a:endParaRPr lang="en-US"/>
           </a:p>
@@ -911,7 +921,7 @@
           <a:p>
             <a:fld id="{7DEE96FE-DC9C-4536-9FF4-6BA93424ACA5}" type="datetimeFigureOut">
               <a:rPr lang="en-US" smtClean="0"/>
-              <a:t>2/27/2026</a:t>
+              <a:t>2/28/2026</a:t>
             </a:fld>
             <a:endParaRPr lang="en-US"/>
           </a:p>
@@ -1186,7 +1196,7 @@
           <a:p>
             <a:fld id="{7DEE96FE-DC9C-4536-9FF4-6BA93424ACA5}" type="datetimeFigureOut">
               <a:rPr lang="en-US" smtClean="0"/>
-              <a:t>2/27/2026</a:t>
+              <a:t>2/28/2026</a:t>
             </a:fld>
             <a:endParaRPr lang="en-US"/>
           </a:p>
@@ -1451,7 +1461,7 @@
           <a:p>
             <a:fld id="{7DEE96FE-DC9C-4536-9FF4-6BA93424ACA5}" type="datetimeFigureOut">
               <a:rPr lang="en-US" smtClean="0"/>
-              <a:t>2/27/2026</a:t>
+              <a:t>2/28/2026</a:t>
             </a:fld>
             <a:endParaRPr lang="en-US"/>
           </a:p>
@@ -1863,7 +1873,7 @@
           <a:p>
             <a:fld id="{7DEE96FE-DC9C-4536-9FF4-6BA93424ACA5}" type="datetimeFigureOut">
               <a:rPr lang="en-US" smtClean="0"/>
-              <a:t>2/27/2026</a:t>
+              <a:t>2/28/2026</a:t>
             </a:fld>
             <a:endParaRPr lang="en-US"/>
           </a:p>
@@ -2004,7 +2014,7 @@
           <a:p>
             <a:fld id="{7DEE96FE-DC9C-4536-9FF4-6BA93424ACA5}" type="datetimeFigureOut">
               <a:rPr lang="en-US" smtClean="0"/>
-              <a:t>2/27/2026</a:t>
+              <a:t>2/28/2026</a:t>
             </a:fld>
             <a:endParaRPr lang="en-US"/>
           </a:p>
@@ -2117,7 +2127,7 @@
           <a:p>
             <a:fld id="{7DEE96FE-DC9C-4536-9FF4-6BA93424ACA5}" type="datetimeFigureOut">
               <a:rPr lang="en-US" smtClean="0"/>
-              <a:t>2/27/2026</a:t>
+              <a:t>2/28/2026</a:t>
             </a:fld>
             <a:endParaRPr lang="en-US"/>
           </a:p>
@@ -2428,7 +2438,7 @@
           <a:p>
             <a:fld id="{7DEE96FE-DC9C-4536-9FF4-6BA93424ACA5}" type="datetimeFigureOut">
               <a:rPr lang="en-US" smtClean="0"/>
-              <a:t>2/27/2026</a:t>
+              <a:t>2/28/2026</a:t>
             </a:fld>
             <a:endParaRPr lang="en-US"/>
           </a:p>
@@ -2716,7 +2726,7 @@
           <a:p>
             <a:fld id="{7DEE96FE-DC9C-4536-9FF4-6BA93424ACA5}" type="datetimeFigureOut">
               <a:rPr lang="en-US" smtClean="0"/>
-              <a:t>2/27/2026</a:t>
+              <a:t>2/28/2026</a:t>
             </a:fld>
             <a:endParaRPr lang="en-US"/>
           </a:p>
@@ -2957,7 +2967,7 @@
           <a:p>
             <a:fld id="{7DEE96FE-DC9C-4536-9FF4-6BA93424ACA5}" type="datetimeFigureOut">
               <a:rPr lang="en-US" smtClean="0"/>
-              <a:t>2/27/2026</a:t>
+              <a:t>2/28/2026</a:t>
             </a:fld>
             <a:endParaRPr lang="en-US"/>
           </a:p>
@@ -3475,10 +3485,418 @@
           <a:chExt cx="0" cy="0"/>
         </a:xfrm>
       </p:grpSpPr>
+      <p:sp>
+        <p:nvSpPr>
+          <p:cNvPr id="2" name="TextBox 1">
+            <a:extLst>
+              <a:ext uri="{FF2B5EF4-FFF2-40B4-BE49-F238E27FC236}">
+                <a16:creationId xmlns:a16="http://schemas.microsoft.com/office/drawing/2014/main" id="{D9F80F84-7DA0-EDA6-93EE-7BDA4A105B5A}"/>
+              </a:ext>
+            </a:extLst>
+          </p:cNvPr>
+          <p:cNvSpPr txBox="1"/>
+          <p:nvPr/>
+        </p:nvSpPr>
+        <p:spPr>
+          <a:xfrm>
+            <a:off x="597877" y="518746"/>
+            <a:ext cx="2092569" cy="646331"/>
+          </a:xfrm>
+          <a:prstGeom prst="rect">
+            <a:avLst/>
+          </a:prstGeom>
+          <a:noFill/>
+        </p:spPr>
+        <p:txBody>
+          <a:bodyPr wrap="square" rtlCol="0">
+            <a:spAutoFit/>
+          </a:bodyPr>
+          <a:lstStyle/>
+          <a:p>
+            <a:r>
+              <a:rPr lang="en-US" dirty="0"/>
+              <a:t>Adding Azure Functions app</a:t>
+            </a:r>
+          </a:p>
+        </p:txBody>
+      </p:sp>
+      <p:pic>
+        <p:nvPicPr>
+          <p:cNvPr id="4" name="Picture 3">
+            <a:extLst>
+              <a:ext uri="{FF2B5EF4-FFF2-40B4-BE49-F238E27FC236}">
+                <a16:creationId xmlns:a16="http://schemas.microsoft.com/office/drawing/2014/main" id="{E39A70FC-FEF1-384C-3C52-FD79809C6C4D}"/>
+              </a:ext>
+            </a:extLst>
+          </p:cNvPr>
+          <p:cNvPicPr>
+            <a:picLocks noChangeAspect="1"/>
+          </p:cNvPicPr>
+          <p:nvPr/>
+        </p:nvPicPr>
+        <p:blipFill>
+          <a:blip r:embed="rId2"/>
+          <a:stretch>
+            <a:fillRect/>
+          </a:stretch>
+        </p:blipFill>
+        <p:spPr>
+          <a:xfrm>
+            <a:off x="1814914" y="0"/>
+            <a:ext cx="8562172" cy="6858000"/>
+          </a:xfrm>
+          <a:prstGeom prst="rect">
+            <a:avLst/>
+          </a:prstGeom>
+        </p:spPr>
+      </p:pic>
     </p:spTree>
     <p:extLst>
       <p:ext uri="{BB962C8B-B14F-4D97-AF65-F5344CB8AC3E}">
         <p14:creationId xmlns:p14="http://schemas.microsoft.com/office/powerpoint/2010/main" val="993993506"/>
+      </p:ext>
+    </p:extLst>
+  </p:cSld>
+  <p:clrMapOvr>
+    <a:masterClrMapping/>
+  </p:clrMapOvr>
+</p:sld>
+</file>
+
+<file path=ppt/slides/slide3.xml><?xml version="1.0" encoding="utf-8"?>
+<p:sld xmlns:a="http://schemas.openxmlformats.org/drawingml/2006/main" xmlns:r="http://schemas.openxmlformats.org/officeDocument/2006/relationships" xmlns:p="http://schemas.openxmlformats.org/presentationml/2006/main">
+  <p:cSld>
+    <p:spTree>
+      <p:nvGrpSpPr>
+        <p:cNvPr id="1" name=""/>
+        <p:cNvGrpSpPr/>
+        <p:nvPr/>
+      </p:nvGrpSpPr>
+      <p:grpSpPr>
+        <a:xfrm>
+          <a:off x="0" y="0"/>
+          <a:ext cx="0" cy="0"/>
+          <a:chOff x="0" y="0"/>
+          <a:chExt cx="0" cy="0"/>
+        </a:xfrm>
+      </p:grpSpPr>
+      <p:pic>
+        <p:nvPicPr>
+          <p:cNvPr id="3" name="Picture 2">
+            <a:extLst>
+              <a:ext uri="{FF2B5EF4-FFF2-40B4-BE49-F238E27FC236}">
+                <a16:creationId xmlns:a16="http://schemas.microsoft.com/office/drawing/2014/main" id="{FF8D535B-A547-10A7-7968-004EB1FC81FF}"/>
+              </a:ext>
+            </a:extLst>
+          </p:cNvPr>
+          <p:cNvPicPr>
+            <a:picLocks noChangeAspect="1"/>
+          </p:cNvPicPr>
+          <p:nvPr/>
+        </p:nvPicPr>
+        <p:blipFill>
+          <a:blip r:embed="rId2"/>
+          <a:stretch>
+            <a:fillRect/>
+          </a:stretch>
+        </p:blipFill>
+        <p:spPr>
+          <a:xfrm>
+            <a:off x="1814914" y="0"/>
+            <a:ext cx="8562172" cy="6858000"/>
+          </a:xfrm>
+          <a:prstGeom prst="rect">
+            <a:avLst/>
+          </a:prstGeom>
+        </p:spPr>
+      </p:pic>
+    </p:spTree>
+    <p:extLst>
+      <p:ext uri="{BB962C8B-B14F-4D97-AF65-F5344CB8AC3E}">
+        <p14:creationId xmlns:p14="http://schemas.microsoft.com/office/powerpoint/2010/main" val="3720972096"/>
+      </p:ext>
+    </p:extLst>
+  </p:cSld>
+  <p:clrMapOvr>
+    <a:masterClrMapping/>
+  </p:clrMapOvr>
+</p:sld>
+</file>
+
+<file path=ppt/slides/slide4.xml><?xml version="1.0" encoding="utf-8"?>
+<p:sld xmlns:a="http://schemas.openxmlformats.org/drawingml/2006/main" xmlns:r="http://schemas.openxmlformats.org/officeDocument/2006/relationships" xmlns:p="http://schemas.openxmlformats.org/presentationml/2006/main">
+  <p:cSld>
+    <p:spTree>
+      <p:nvGrpSpPr>
+        <p:cNvPr id="1" name=""/>
+        <p:cNvGrpSpPr/>
+        <p:nvPr/>
+      </p:nvGrpSpPr>
+      <p:grpSpPr>
+        <a:xfrm>
+          <a:off x="0" y="0"/>
+          <a:ext cx="0" cy="0"/>
+          <a:chOff x="0" y="0"/>
+          <a:chExt cx="0" cy="0"/>
+        </a:xfrm>
+      </p:grpSpPr>
+      <p:pic>
+        <p:nvPicPr>
+          <p:cNvPr id="3" name="Picture 2">
+            <a:extLst>
+              <a:ext uri="{FF2B5EF4-FFF2-40B4-BE49-F238E27FC236}">
+                <a16:creationId xmlns:a16="http://schemas.microsoft.com/office/drawing/2014/main" id="{9823891C-D735-0137-4920-8D4F33286F1F}"/>
+              </a:ext>
+            </a:extLst>
+          </p:cNvPr>
+          <p:cNvPicPr>
+            <a:picLocks noChangeAspect="1"/>
+          </p:cNvPicPr>
+          <p:nvPr/>
+        </p:nvPicPr>
+        <p:blipFill>
+          <a:blip r:embed="rId2"/>
+          <a:stretch>
+            <a:fillRect/>
+          </a:stretch>
+        </p:blipFill>
+        <p:spPr>
+          <a:xfrm>
+            <a:off x="1814914" y="0"/>
+            <a:ext cx="8562172" cy="6858000"/>
+          </a:xfrm>
+          <a:prstGeom prst="rect">
+            <a:avLst/>
+          </a:prstGeom>
+        </p:spPr>
+      </p:pic>
+    </p:spTree>
+    <p:extLst>
+      <p:ext uri="{BB962C8B-B14F-4D97-AF65-F5344CB8AC3E}">
+        <p14:creationId xmlns:p14="http://schemas.microsoft.com/office/powerpoint/2010/main" val="83128248"/>
+      </p:ext>
+    </p:extLst>
+  </p:cSld>
+  <p:clrMapOvr>
+    <a:masterClrMapping/>
+  </p:clrMapOvr>
+</p:sld>
+</file>
+
+<file path=ppt/slides/slide5.xml><?xml version="1.0" encoding="utf-8"?>
+<p:sld xmlns:a="http://schemas.openxmlformats.org/drawingml/2006/main" xmlns:r="http://schemas.openxmlformats.org/officeDocument/2006/relationships" xmlns:p="http://schemas.openxmlformats.org/presentationml/2006/main">
+  <p:cSld>
+    <p:spTree>
+      <p:nvGrpSpPr>
+        <p:cNvPr id="1" name=""/>
+        <p:cNvGrpSpPr/>
+        <p:nvPr/>
+      </p:nvGrpSpPr>
+      <p:grpSpPr>
+        <a:xfrm>
+          <a:off x="0" y="0"/>
+          <a:ext cx="0" cy="0"/>
+          <a:chOff x="0" y="0"/>
+          <a:chExt cx="0" cy="0"/>
+        </a:xfrm>
+      </p:grpSpPr>
+      <p:pic>
+        <p:nvPicPr>
+          <p:cNvPr id="3" name="Picture 2">
+            <a:extLst>
+              <a:ext uri="{FF2B5EF4-FFF2-40B4-BE49-F238E27FC236}">
+                <a16:creationId xmlns:a16="http://schemas.microsoft.com/office/drawing/2014/main" id="{B7FE5DFF-C9E8-67CC-95B2-5E4F19517EE2}"/>
+              </a:ext>
+            </a:extLst>
+          </p:cNvPr>
+          <p:cNvPicPr>
+            <a:picLocks noChangeAspect="1"/>
+          </p:cNvPicPr>
+          <p:nvPr/>
+        </p:nvPicPr>
+        <p:blipFill>
+          <a:blip r:embed="rId2"/>
+          <a:stretch>
+            <a:fillRect/>
+          </a:stretch>
+        </p:blipFill>
+        <p:spPr>
+          <a:xfrm>
+            <a:off x="1814914" y="0"/>
+            <a:ext cx="8562172" cy="6858000"/>
+          </a:xfrm>
+          <a:prstGeom prst="rect">
+            <a:avLst/>
+          </a:prstGeom>
+        </p:spPr>
+      </p:pic>
+    </p:spTree>
+    <p:extLst>
+      <p:ext uri="{BB962C8B-B14F-4D97-AF65-F5344CB8AC3E}">
+        <p14:creationId xmlns:p14="http://schemas.microsoft.com/office/powerpoint/2010/main" val="2125830670"/>
+      </p:ext>
+    </p:extLst>
+  </p:cSld>
+  <p:clrMapOvr>
+    <a:masterClrMapping/>
+  </p:clrMapOvr>
+</p:sld>
+</file>
+
+<file path=ppt/slides/slide6.xml><?xml version="1.0" encoding="utf-8"?>
+<p:sld xmlns:a="http://schemas.openxmlformats.org/drawingml/2006/main" xmlns:r="http://schemas.openxmlformats.org/officeDocument/2006/relationships" xmlns:p="http://schemas.openxmlformats.org/presentationml/2006/main">
+  <p:cSld>
+    <p:spTree>
+      <p:nvGrpSpPr>
+        <p:cNvPr id="1" name=""/>
+        <p:cNvGrpSpPr/>
+        <p:nvPr/>
+      </p:nvGrpSpPr>
+      <p:grpSpPr>
+        <a:xfrm>
+          <a:off x="0" y="0"/>
+          <a:ext cx="0" cy="0"/>
+          <a:chOff x="0" y="0"/>
+          <a:chExt cx="0" cy="0"/>
+        </a:xfrm>
+      </p:grpSpPr>
+      <p:pic>
+        <p:nvPicPr>
+          <p:cNvPr id="3" name="Picture 2">
+            <a:extLst>
+              <a:ext uri="{FF2B5EF4-FFF2-40B4-BE49-F238E27FC236}">
+                <a16:creationId xmlns:a16="http://schemas.microsoft.com/office/drawing/2014/main" id="{7227FB9D-3E38-3707-FC4E-AAD21489BE27}"/>
+              </a:ext>
+            </a:extLst>
+          </p:cNvPr>
+          <p:cNvPicPr>
+            <a:picLocks noChangeAspect="1"/>
+          </p:cNvPicPr>
+          <p:nvPr/>
+        </p:nvPicPr>
+        <p:blipFill>
+          <a:blip r:embed="rId2"/>
+          <a:stretch>
+            <a:fillRect/>
+          </a:stretch>
+        </p:blipFill>
+        <p:spPr>
+          <a:xfrm>
+            <a:off x="4616674" y="0"/>
+            <a:ext cx="7575326" cy="6858000"/>
+          </a:xfrm>
+          <a:prstGeom prst="rect">
+            <a:avLst/>
+          </a:prstGeom>
+        </p:spPr>
+      </p:pic>
+      <p:sp>
+        <p:nvSpPr>
+          <p:cNvPr id="4" name="TextBox 3">
+            <a:extLst>
+              <a:ext uri="{FF2B5EF4-FFF2-40B4-BE49-F238E27FC236}">
+                <a16:creationId xmlns:a16="http://schemas.microsoft.com/office/drawing/2014/main" id="{19D66657-158B-83E6-8AA2-49589CF72AE4}"/>
+              </a:ext>
+            </a:extLst>
+          </p:cNvPr>
+          <p:cNvSpPr txBox="1"/>
+          <p:nvPr/>
+        </p:nvSpPr>
+        <p:spPr>
+          <a:xfrm>
+            <a:off x="430823" y="465992"/>
+            <a:ext cx="2699239" cy="1754326"/>
+          </a:xfrm>
+          <a:prstGeom prst="rect">
+            <a:avLst/>
+          </a:prstGeom>
+          <a:noFill/>
+        </p:spPr>
+        <p:txBody>
+          <a:bodyPr wrap="square" rtlCol="0">
+            <a:spAutoFit/>
+          </a:bodyPr>
+          <a:lstStyle/>
+          <a:p>
+            <a:r>
+              <a:rPr lang="en-US" dirty="0"/>
+              <a:t>Scary! Had to read this over a few times. I need Outbound public access to SQL over the </a:t>
+            </a:r>
+            <a:r>
+              <a:rPr lang="en-US" dirty="0" err="1"/>
+              <a:t>vnet</a:t>
+            </a:r>
+            <a:r>
+              <a:rPr lang="en-US" dirty="0"/>
+              <a:t> and Inbound public for testing.</a:t>
+            </a:r>
+          </a:p>
+        </p:txBody>
+      </p:sp>
+    </p:spTree>
+    <p:extLst>
+      <p:ext uri="{BB962C8B-B14F-4D97-AF65-F5344CB8AC3E}">
+        <p14:creationId xmlns:p14="http://schemas.microsoft.com/office/powerpoint/2010/main" val="4260335236"/>
+      </p:ext>
+    </p:extLst>
+  </p:cSld>
+  <p:clrMapOvr>
+    <a:masterClrMapping/>
+  </p:clrMapOvr>
+</p:sld>
+</file>
+
+<file path=ppt/slides/slide7.xml><?xml version="1.0" encoding="utf-8"?>
+<p:sld xmlns:a="http://schemas.openxmlformats.org/drawingml/2006/main" xmlns:r="http://schemas.openxmlformats.org/officeDocument/2006/relationships" xmlns:p="http://schemas.openxmlformats.org/presentationml/2006/main">
+  <p:cSld>
+    <p:spTree>
+      <p:nvGrpSpPr>
+        <p:cNvPr id="1" name=""/>
+        <p:cNvGrpSpPr/>
+        <p:nvPr/>
+      </p:nvGrpSpPr>
+      <p:grpSpPr>
+        <a:xfrm>
+          <a:off x="0" y="0"/>
+          <a:ext cx="0" cy="0"/>
+          <a:chOff x="0" y="0"/>
+          <a:chExt cx="0" cy="0"/>
+        </a:xfrm>
+      </p:grpSpPr>
+      <p:pic>
+        <p:nvPicPr>
+          <p:cNvPr id="3" name="Picture 2">
+            <a:extLst>
+              <a:ext uri="{FF2B5EF4-FFF2-40B4-BE49-F238E27FC236}">
+                <a16:creationId xmlns:a16="http://schemas.microsoft.com/office/drawing/2014/main" id="{F19187BC-CA8E-BE47-ADB1-3BB7EB7A4D5A}"/>
+              </a:ext>
+            </a:extLst>
+          </p:cNvPr>
+          <p:cNvPicPr>
+            <a:picLocks noChangeAspect="1"/>
+          </p:cNvPicPr>
+          <p:nvPr/>
+        </p:nvPicPr>
+        <p:blipFill>
+          <a:blip r:embed="rId2"/>
+          <a:stretch>
+            <a:fillRect/>
+          </a:stretch>
+        </p:blipFill>
+        <p:spPr>
+          <a:xfrm>
+            <a:off x="4616674" y="0"/>
+            <a:ext cx="7575326" cy="6858000"/>
+          </a:xfrm>
+          <a:prstGeom prst="rect">
+            <a:avLst/>
+          </a:prstGeom>
+        </p:spPr>
+      </p:pic>
+    </p:spTree>
+    <p:extLst>
+      <p:ext uri="{BB962C8B-B14F-4D97-AF65-F5344CB8AC3E}">
+        <p14:creationId xmlns:p14="http://schemas.microsoft.com/office/powerpoint/2010/main" val="165184747"/>
       </p:ext>
     </p:extLst>
   </p:cSld>

</xml_diff>

<commit_message>
Feat: Implement customer portal placeholder & secure help desk page
</commit_message>
<xml_diff>
--- a/References/ProjectSnaps.pptx
+++ b/References/ProjectSnaps.pptx
@@ -20,6 +20,9 @@
     <p:sldId id="268" r:id="rId14"/>
     <p:sldId id="269" r:id="rId15"/>
     <p:sldId id="270" r:id="rId16"/>
+    <p:sldId id="271" r:id="rId17"/>
+    <p:sldId id="272" r:id="rId18"/>
+    <p:sldId id="273" r:id="rId19"/>
   </p:sldIdLst>
   <p:sldSz cx="12192000" cy="6858000"/>
   <p:notesSz cx="6858000" cy="9144000"/>
@@ -4020,10 +4023,307 @@
           <a:chExt cx="0" cy="0"/>
         </a:xfrm>
       </p:grpSpPr>
+      <p:pic>
+        <p:nvPicPr>
+          <p:cNvPr id="3" name="Picture 2">
+            <a:extLst>
+              <a:ext uri="{FF2B5EF4-FFF2-40B4-BE49-F238E27FC236}">
+                <a16:creationId xmlns:a16="http://schemas.microsoft.com/office/drawing/2014/main" id="{D0BAF048-E1EA-CD54-061E-85C58DD3E732}"/>
+              </a:ext>
+            </a:extLst>
+          </p:cNvPr>
+          <p:cNvPicPr>
+            <a:picLocks noChangeAspect="1"/>
+          </p:cNvPicPr>
+          <p:nvPr/>
+        </p:nvPicPr>
+        <p:blipFill>
+          <a:blip r:embed="rId2"/>
+          <a:stretch>
+            <a:fillRect/>
+          </a:stretch>
+        </p:blipFill>
+        <p:spPr>
+          <a:xfrm>
+            <a:off x="4616674" y="0"/>
+            <a:ext cx="7575326" cy="6858000"/>
+          </a:xfrm>
+          <a:prstGeom prst="rect">
+            <a:avLst/>
+          </a:prstGeom>
+        </p:spPr>
+      </p:pic>
+      <p:sp>
+        <p:nvSpPr>
+          <p:cNvPr id="4" name="TextBox 3">
+            <a:extLst>
+              <a:ext uri="{FF2B5EF4-FFF2-40B4-BE49-F238E27FC236}">
+                <a16:creationId xmlns:a16="http://schemas.microsoft.com/office/drawing/2014/main" id="{E4B5D688-0D98-1401-78D2-7516057BA2C5}"/>
+              </a:ext>
+            </a:extLst>
+          </p:cNvPr>
+          <p:cNvSpPr txBox="1"/>
+          <p:nvPr/>
+        </p:nvSpPr>
+        <p:spPr>
+          <a:xfrm>
+            <a:off x="79843" y="492370"/>
+            <a:ext cx="4536831" cy="3139321"/>
+          </a:xfrm>
+          <a:prstGeom prst="rect">
+            <a:avLst/>
+          </a:prstGeom>
+          <a:noFill/>
+        </p:spPr>
+        <p:txBody>
+          <a:bodyPr wrap="square" rtlCol="0">
+            <a:spAutoFit/>
+          </a:bodyPr>
+          <a:lstStyle/>
+          <a:p>
+            <a:r>
+              <a:rPr lang="en-US" dirty="0"/>
+              <a:t>Authorize GitHub</a:t>
+            </a:r>
+          </a:p>
+          <a:p>
+            <a:r>
+              <a:rPr lang="en-US" dirty="0"/>
+              <a:t>App Service will place a GitHub Actions workflow in your chosen repository to build and deploy your app whenever there is a commit on the chosen branch. If you can't find an organization or repository, you may need to enable additional permissions on GitHub. You must have write access to your chosen GitHub repository to deploy with GitHub Actions.</a:t>
+            </a:r>
+            <a:br>
+              <a:rPr lang="en-US" dirty="0">
+                <a:hlinkClick r:id="rId3"/>
+              </a:rPr>
+            </a:br>
+            <a:endParaRPr lang="en-US" dirty="0"/>
+          </a:p>
+        </p:txBody>
+      </p:sp>
     </p:spTree>
     <p:extLst>
       <p:ext uri="{BB962C8B-B14F-4D97-AF65-F5344CB8AC3E}">
         <p14:creationId xmlns:p14="http://schemas.microsoft.com/office/powerpoint/2010/main" val="3166843967"/>
+      </p:ext>
+    </p:extLst>
+  </p:cSld>
+  <p:clrMapOvr>
+    <a:masterClrMapping/>
+  </p:clrMapOvr>
+</p:sld>
+</file>
+
+<file path=ppt/slides/slide16.xml><?xml version="1.0" encoding="utf-8"?>
+<p:sld xmlns:a="http://schemas.openxmlformats.org/drawingml/2006/main" xmlns:r="http://schemas.openxmlformats.org/officeDocument/2006/relationships" xmlns:p="http://schemas.openxmlformats.org/presentationml/2006/main">
+  <p:cSld>
+    <p:spTree>
+      <p:nvGrpSpPr>
+        <p:cNvPr id="1" name=""/>
+        <p:cNvGrpSpPr/>
+        <p:nvPr/>
+      </p:nvGrpSpPr>
+      <p:grpSpPr>
+        <a:xfrm>
+          <a:off x="0" y="0"/>
+          <a:ext cx="0" cy="0"/>
+          <a:chOff x="0" y="0"/>
+          <a:chExt cx="0" cy="0"/>
+        </a:xfrm>
+      </p:grpSpPr>
+      <p:pic>
+        <p:nvPicPr>
+          <p:cNvPr id="3" name="Picture 2">
+            <a:extLst>
+              <a:ext uri="{FF2B5EF4-FFF2-40B4-BE49-F238E27FC236}">
+                <a16:creationId xmlns:a16="http://schemas.microsoft.com/office/drawing/2014/main" id="{7EBFAD50-FD5C-8D6A-6B06-37D770AB632F}"/>
+              </a:ext>
+            </a:extLst>
+          </p:cNvPr>
+          <p:cNvPicPr>
+            <a:picLocks noChangeAspect="1"/>
+          </p:cNvPicPr>
+          <p:nvPr/>
+        </p:nvPicPr>
+        <p:blipFill>
+          <a:blip r:embed="rId2"/>
+          <a:stretch>
+            <a:fillRect/>
+          </a:stretch>
+        </p:blipFill>
+        <p:spPr>
+          <a:xfrm>
+            <a:off x="0" y="685483"/>
+            <a:ext cx="12192000" cy="5487034"/>
+          </a:xfrm>
+          <a:prstGeom prst="rect">
+            <a:avLst/>
+          </a:prstGeom>
+        </p:spPr>
+      </p:pic>
+    </p:spTree>
+    <p:extLst>
+      <p:ext uri="{BB962C8B-B14F-4D97-AF65-F5344CB8AC3E}">
+        <p14:creationId xmlns:p14="http://schemas.microsoft.com/office/powerpoint/2010/main" val="3941072156"/>
+      </p:ext>
+    </p:extLst>
+  </p:cSld>
+  <p:clrMapOvr>
+    <a:masterClrMapping/>
+  </p:clrMapOvr>
+</p:sld>
+</file>
+
+<file path=ppt/slides/slide17.xml><?xml version="1.0" encoding="utf-8"?>
+<p:sld xmlns:a="http://schemas.openxmlformats.org/drawingml/2006/main" xmlns:r="http://schemas.openxmlformats.org/officeDocument/2006/relationships" xmlns:p="http://schemas.openxmlformats.org/presentationml/2006/main">
+  <p:cSld>
+    <p:spTree>
+      <p:nvGrpSpPr>
+        <p:cNvPr id="1" name=""/>
+        <p:cNvGrpSpPr/>
+        <p:nvPr/>
+      </p:nvGrpSpPr>
+      <p:grpSpPr>
+        <a:xfrm>
+          <a:off x="0" y="0"/>
+          <a:ext cx="0" cy="0"/>
+          <a:chOff x="0" y="0"/>
+          <a:chExt cx="0" cy="0"/>
+        </a:xfrm>
+      </p:grpSpPr>
+      <p:pic>
+        <p:nvPicPr>
+          <p:cNvPr id="3" name="Picture 2">
+            <a:extLst>
+              <a:ext uri="{FF2B5EF4-FFF2-40B4-BE49-F238E27FC236}">
+                <a16:creationId xmlns:a16="http://schemas.microsoft.com/office/drawing/2014/main" id="{BC67BBB8-8A93-89BC-0D2C-D1D52E50192D}"/>
+              </a:ext>
+            </a:extLst>
+          </p:cNvPr>
+          <p:cNvPicPr>
+            <a:picLocks noChangeAspect="1"/>
+          </p:cNvPicPr>
+          <p:nvPr/>
+        </p:nvPicPr>
+        <p:blipFill>
+          <a:blip r:embed="rId2"/>
+          <a:stretch>
+            <a:fillRect/>
+          </a:stretch>
+        </p:blipFill>
+        <p:spPr>
+          <a:xfrm>
+            <a:off x="4616674" y="0"/>
+            <a:ext cx="7575326" cy="6858000"/>
+          </a:xfrm>
+          <a:prstGeom prst="rect">
+            <a:avLst/>
+          </a:prstGeom>
+        </p:spPr>
+      </p:pic>
+      <p:sp>
+        <p:nvSpPr>
+          <p:cNvPr id="4" name="TextBox 3">
+            <a:extLst>
+              <a:ext uri="{FF2B5EF4-FFF2-40B4-BE49-F238E27FC236}">
+                <a16:creationId xmlns:a16="http://schemas.microsoft.com/office/drawing/2014/main" id="{1F5FAEA7-2694-3CFD-FE88-5C2BE935249E}"/>
+              </a:ext>
+            </a:extLst>
+          </p:cNvPr>
+          <p:cNvSpPr txBox="1"/>
+          <p:nvPr/>
+        </p:nvSpPr>
+        <p:spPr>
+          <a:xfrm>
+            <a:off x="923192" y="606669"/>
+            <a:ext cx="2400300" cy="369332"/>
+          </a:xfrm>
+          <a:prstGeom prst="rect">
+            <a:avLst/>
+          </a:prstGeom>
+          <a:noFill/>
+        </p:spPr>
+        <p:txBody>
+          <a:bodyPr wrap="square" rtlCol="0">
+            <a:spAutoFit/>
+          </a:bodyPr>
+          <a:lstStyle/>
+          <a:p>
+            <a:r>
+              <a:rPr lang="en-US" dirty="0"/>
+              <a:t>Finishing GitHub auth</a:t>
+            </a:r>
+          </a:p>
+        </p:txBody>
+      </p:sp>
+    </p:spTree>
+    <p:extLst>
+      <p:ext uri="{BB962C8B-B14F-4D97-AF65-F5344CB8AC3E}">
+        <p14:creationId xmlns:p14="http://schemas.microsoft.com/office/powerpoint/2010/main" val="504004102"/>
+      </p:ext>
+    </p:extLst>
+  </p:cSld>
+  <p:clrMapOvr>
+    <a:masterClrMapping/>
+  </p:clrMapOvr>
+</p:sld>
+</file>
+
+<file path=ppt/slides/slide18.xml><?xml version="1.0" encoding="utf-8"?>
+<p:sld xmlns:a="http://schemas.openxmlformats.org/drawingml/2006/main" xmlns:r="http://schemas.openxmlformats.org/officeDocument/2006/relationships" xmlns:p="http://schemas.openxmlformats.org/presentationml/2006/main">
+  <p:cSld>
+    <p:spTree>
+      <p:nvGrpSpPr>
+        <p:cNvPr id="1" name=""/>
+        <p:cNvGrpSpPr/>
+        <p:nvPr/>
+      </p:nvGrpSpPr>
+      <p:grpSpPr>
+        <a:xfrm>
+          <a:off x="0" y="0"/>
+          <a:ext cx="0" cy="0"/>
+          <a:chOff x="0" y="0"/>
+          <a:chExt cx="0" cy="0"/>
+        </a:xfrm>
+      </p:grpSpPr>
+      <p:sp>
+        <p:nvSpPr>
+          <p:cNvPr id="2" name="TextBox 1">
+            <a:extLst>
+              <a:ext uri="{FF2B5EF4-FFF2-40B4-BE49-F238E27FC236}">
+                <a16:creationId xmlns:a16="http://schemas.microsoft.com/office/drawing/2014/main" id="{5C563D94-AEF0-25D6-1948-F1E9BAC0FEDD}"/>
+              </a:ext>
+            </a:extLst>
+          </p:cNvPr>
+          <p:cNvSpPr txBox="1"/>
+          <p:nvPr/>
+        </p:nvSpPr>
+        <p:spPr>
+          <a:xfrm>
+            <a:off x="1028700" y="1195754"/>
+            <a:ext cx="2268415" cy="369332"/>
+          </a:xfrm>
+          <a:prstGeom prst="rect">
+            <a:avLst/>
+          </a:prstGeom>
+          <a:noFill/>
+        </p:spPr>
+        <p:txBody>
+          <a:bodyPr wrap="square" rtlCol="0">
+            <a:spAutoFit/>
+          </a:bodyPr>
+          <a:lstStyle/>
+          <a:p>
+            <a:r>
+              <a:rPr lang="en-US"/>
+              <a:t>sadf</a:t>
+            </a:r>
+          </a:p>
+        </p:txBody>
+      </p:sp>
+    </p:spTree>
+    <p:extLst>
+      <p:ext uri="{BB962C8B-B14F-4D97-AF65-F5344CB8AC3E}">
+        <p14:creationId xmlns:p14="http://schemas.microsoft.com/office/powerpoint/2010/main" val="620128126"/>
       </p:ext>
     </p:extLst>
   </p:cSld>

</xml_diff>